<commit_message>
Desain ulang kartu hasil kalibrasi: angka utama, sebelum-sesudah, dan alasan singkat
Co-Authored-By: Claude Opus 5.5 <noreply@anthropic.com>
Claude-Session: https://claude.ai/code/session_01RwTK1q8JkWDwXbpfgwmLot
</commit_message>
<xml_diff>
--- a/Slide - Kalibrasi Hasil Tiap Tahap.pptx
+++ b/Slide - Kalibrasi Hasil Tiap Tahap.pptx
@@ -6012,15 +6012,15 @@
         <p:spPr>
           <a:xfrm>
             <a:off x="822960" y="1783080"/>
-            <a:ext cx="3200400" cy="5989320"/>
+            <a:ext cx="3200400" cy="5943600"/>
           </a:xfrm>
           <a:prstGeom prst="roundRect">
             <a:avLst>
-              <a:gd name="adj" fmla="val 8000"/>
+              <a:gd name="adj" fmla="val 5000"/>
             </a:avLst>
           </a:prstGeom>
           <a:solidFill>
-            <a:srgbClr val="EAF8FA"/>
+            <a:srgbClr val="FFFFFF"/>
           </a:solidFill>
           <a:ln w="12700">
             <a:solidFill>
@@ -6044,7 +6044,53 @@
           </a:fontRef>
         </p:style>
         <p:txBody>
-          <a:bodyPr rtlCol="0" anchor="t" wrap="square" lIns="128016" rIns="128016" tIns="109728" bIns="109728"/>
+          <a:bodyPr rtlCol="0" anchor="t" wrap="square" lIns="164592" rIns="164592" tIns="109728" bIns="109728"/>
+          <a:lstStyle/>
+          <a:p>
+            <a:pPr algn="ctr"/>
+          </a:p>
+        </p:txBody>
+      </p:sp>
+      <p:sp>
+        <p:nvSpPr>
+          <p:cNvPr id="157" name="Rounded Rectangle 156"/>
+          <p:cNvSpPr/>
+          <p:nvPr/>
+        </p:nvSpPr>
+        <p:spPr>
+          <a:xfrm>
+            <a:off x="822960" y="1783080"/>
+            <a:ext cx="3200400" cy="777240"/>
+          </a:xfrm>
+          <a:prstGeom prst="roundRect">
+            <a:avLst>
+              <a:gd name="adj" fmla="val 12000"/>
+            </a:avLst>
+          </a:prstGeom>
+          <a:solidFill>
+            <a:srgbClr val="5E6E78"/>
+          </a:solidFill>
+          <a:ln>
+            <a:noFill/>
+          </a:ln>
+          <a:effectLst/>
+        </p:spPr>
+        <p:style>
+          <a:lnRef idx="1">
+            <a:schemeClr val="accent1"/>
+          </a:lnRef>
+          <a:fillRef idx="3">
+            <a:schemeClr val="accent1"/>
+          </a:fillRef>
+          <a:effectRef idx="2">
+            <a:schemeClr val="accent1"/>
+          </a:effectRef>
+          <a:fontRef idx="minor">
+            <a:schemeClr val="lt1"/>
+          </a:fontRef>
+        </p:style>
+        <p:txBody>
+          <a:bodyPr rtlCol="0" anchor="ctr" wrap="square" lIns="137160" rIns="137160" tIns="109728" bIns="109728"/>
           <a:lstStyle/>
           <a:p>
             <a:pPr algn="l">
@@ -6055,7 +6101,7 @@
             <a:r>
               <a:rPr sz="1090" b="1" i="0">
                 <a:solidFill>
-                  <a:srgbClr val="5E6E78"/>
+                  <a:srgbClr val="FFD23B"/>
                 </a:solidFill>
                 <a:latin typeface="Calibri (MS) Bold"/>
               </a:rPr>
@@ -6071,13 +6117,95 @@
             <a:r>
               <a:rPr sz="1440" b="1" i="0">
                 <a:solidFill>
-                  <a:srgbClr val="0B5E6E"/>
+                  <a:srgbClr val="FFFFFF"/>
                 </a:solidFill>
                 <a:latin typeface="Calibri (MS) Bold"/>
               </a:rPr>
               <a:t>Membetulkan cara hitung</a:t>
             </a:r>
           </a:p>
+        </p:txBody>
+      </p:sp>
+      <p:sp>
+        <p:nvSpPr>
+          <p:cNvPr id="158" name="TextBox 157"/>
+          <p:cNvSpPr txBox="1"/>
+          <p:nvPr/>
+        </p:nvSpPr>
+        <p:spPr>
+          <a:xfrm>
+            <a:off x="960120" y="2633472"/>
+            <a:ext cx="2926080" cy="548640"/>
+          </a:xfrm>
+          <a:prstGeom prst="rect">
+            <a:avLst/>
+          </a:prstGeom>
+          <a:noFill/>
+        </p:spPr>
+        <p:txBody>
+          <a:bodyPr wrap="square" anchor="t" lIns="0" rIns="0" tIns="0" bIns="0">
+            <a:spAutoFit/>
+          </a:bodyPr>
+          <a:lstStyle/>
+          <a:p>
+            <a:pPr algn="l">
+              <a:spcAft>
+                <a:spcPts val="400"/>
+              </a:spcAft>
+            </a:pPr>
+            <a:r>
+              <a:rPr sz="1090" b="1" i="1">
+                <a:solidFill>
+                  <a:srgbClr val="14313B"/>
+                </a:solidFill>
+                <a:latin typeface="Calibri (MS) Bold"/>
+              </a:rPr>
+              <a:t>LPE dan LPD (laju pertumbuhan dan penurunan wisatawan)</a:t>
+            </a:r>
+          </a:p>
+        </p:txBody>
+      </p:sp>
+      <p:sp>
+        <p:nvSpPr>
+          <p:cNvPr id="159" name="Rounded Rectangle 158"/>
+          <p:cNvSpPr/>
+          <p:nvPr/>
+        </p:nvSpPr>
+        <p:spPr>
+          <a:xfrm>
+            <a:off x="960120" y="3200400"/>
+            <a:ext cx="2926080" cy="384048"/>
+          </a:xfrm>
+          <a:prstGeom prst="roundRect">
+            <a:avLst>
+              <a:gd name="adj" fmla="val 8000"/>
+            </a:avLst>
+          </a:prstGeom>
+          <a:solidFill>
+            <a:srgbClr val="EAF8FA"/>
+          </a:solidFill>
+          <a:ln>
+            <a:noFill/>
+          </a:ln>
+          <a:effectLst/>
+        </p:spPr>
+        <p:style>
+          <a:lnRef idx="1">
+            <a:schemeClr val="accent1"/>
+          </a:lnRef>
+          <a:fillRef idx="3">
+            <a:schemeClr val="accent1"/>
+          </a:fillRef>
+          <a:effectRef idx="2">
+            <a:schemeClr val="accent1"/>
+          </a:effectRef>
+          <a:fontRef idx="minor">
+            <a:schemeClr val="lt1"/>
+          </a:fontRef>
+        </p:style>
+        <p:txBody>
+          <a:bodyPr rtlCol="0" anchor="ctr" wrap="square" lIns="73152" rIns="73152" tIns="73152" bIns="73152"/>
+          <a:lstStyle/>
           <a:p>
             <a:pPr algn="l">
               <a:spcAft>
@@ -6085,17 +6213,69 @@
               </a:spcAft>
             </a:pPr>
             <a:r>
-              <a:rPr sz="1150" b="1" i="1">
+              <a:rPr sz="1030" b="1" i="0">
+                <a:solidFill>
+                  <a:srgbClr val="0B5E6E"/>
+                </a:solidFill>
+                <a:latin typeface="Calibri (MS) Bold"/>
+              </a:rPr>
+              <a:t>Dicoba: </a:t>
+            </a:r>
+            <a:r>
+              <a:rPr sz="1030" b="0" i="0">
                 <a:solidFill>
                   <a:srgbClr val="14313B"/>
                 </a:solidFill>
-                <a:latin typeface="Calibri (MS) Bold"/>
+                <a:latin typeface="Calibri (MS)"/>
               </a:rPr>
-              <a:t>Laju pertumbuhan eksternal (LPE) dan laju penurunan dasar (LPD) wisatawan</a:t>
-            </a:r>
-          </a:p>
-          <a:p>
-            <a:pPr algn="l">
+              <a:t>Rumus dicek ulang terhadap persamaan model</a:t>
+            </a:r>
+          </a:p>
+        </p:txBody>
+      </p:sp>
+      <p:sp>
+        <p:nvSpPr>
+          <p:cNvPr id="160" name="Rounded Rectangle 159"/>
+          <p:cNvSpPr/>
+          <p:nvPr/>
+        </p:nvSpPr>
+        <p:spPr>
+          <a:xfrm>
+            <a:off x="960120" y="3703320"/>
+            <a:ext cx="2926080" cy="429768"/>
+          </a:xfrm>
+          <a:prstGeom prst="roundRect">
+            <a:avLst>
+              <a:gd name="adj" fmla="val 8000"/>
+            </a:avLst>
+          </a:prstGeom>
+          <a:solidFill>
+            <a:srgbClr val="EAF8FA"/>
+          </a:solidFill>
+          <a:ln>
+            <a:noFill/>
+          </a:ln>
+          <a:effectLst/>
+        </p:spPr>
+        <p:style>
+          <a:lnRef idx="1">
+            <a:schemeClr val="accent1"/>
+          </a:lnRef>
+          <a:fillRef idx="3">
+            <a:schemeClr val="accent1"/>
+          </a:fillRef>
+          <a:effectRef idx="2">
+            <a:schemeClr val="accent1"/>
+          </a:effectRef>
+          <a:fontRef idx="minor">
+            <a:schemeClr val="lt1"/>
+          </a:fontRef>
+        </p:style>
+        <p:txBody>
+          <a:bodyPr rtlCol="0" anchor="ctr" wrap="square" lIns="45720" rIns="45720"/>
+          <a:lstStyle/>
+          <a:p>
+            <a:pPr algn="ctr">
               <a:spcAft>
                 <a:spcPts val="300"/>
               </a:spcAft>
@@ -6107,7 +6287,197 @@
                 </a:solidFill>
                 <a:latin typeface="Calibri (MS) Bold"/>
               </a:rPr>
-              <a:t>Yang dilakukan:  </a:t>
+              <a:t>LPE  </a:t>
+            </a:r>
+            <a:r>
+              <a:rPr sz="1320" b="1" i="0">
+                <a:solidFill>
+                  <a:srgbClr val="14313B"/>
+                </a:solidFill>
+                <a:latin typeface="Calibri (MS) Bold"/>
+              </a:rPr>
+              <a:t>0,26864 → 0,27726</a:t>
+            </a:r>
+          </a:p>
+        </p:txBody>
+      </p:sp>
+      <p:sp>
+        <p:nvSpPr>
+          <p:cNvPr id="161" name="Rounded Rectangle 160"/>
+          <p:cNvSpPr/>
+          <p:nvPr/>
+        </p:nvSpPr>
+        <p:spPr>
+          <a:xfrm>
+            <a:off x="960120" y="4206240"/>
+            <a:ext cx="2926080" cy="429768"/>
+          </a:xfrm>
+          <a:prstGeom prst="roundRect">
+            <a:avLst>
+              <a:gd name="adj" fmla="val 8000"/>
+            </a:avLst>
+          </a:prstGeom>
+          <a:solidFill>
+            <a:srgbClr val="EAF8FA"/>
+          </a:solidFill>
+          <a:ln>
+            <a:noFill/>
+          </a:ln>
+          <a:effectLst/>
+        </p:spPr>
+        <p:style>
+          <a:lnRef idx="1">
+            <a:schemeClr val="accent1"/>
+          </a:lnRef>
+          <a:fillRef idx="3">
+            <a:schemeClr val="accent1"/>
+          </a:fillRef>
+          <a:effectRef idx="2">
+            <a:schemeClr val="accent1"/>
+          </a:effectRef>
+          <a:fontRef idx="minor">
+            <a:schemeClr val="lt1"/>
+          </a:fontRef>
+        </p:style>
+        <p:txBody>
+          <a:bodyPr rtlCol="0" anchor="ctr" wrap="square" lIns="45720" rIns="45720"/>
+          <a:lstStyle/>
+          <a:p>
+            <a:pPr algn="ctr">
+              <a:spcAft>
+                <a:spcPts val="300"/>
+              </a:spcAft>
+            </a:pPr>
+            <a:r>
+              <a:rPr sz="1210" b="1" i="0">
+                <a:solidFill>
+                  <a:srgbClr val="0B5E6E"/>
+                </a:solidFill>
+                <a:latin typeface="Calibri (MS) Bold"/>
+              </a:rPr>
+              <a:t>LPD  </a:t>
+            </a:r>
+            <a:r>
+              <a:rPr sz="1320" b="1" i="0">
+                <a:solidFill>
+                  <a:srgbClr val="14313B"/>
+                </a:solidFill>
+                <a:latin typeface="Calibri (MS) Bold"/>
+              </a:rPr>
+              <a:t>0,20148 → 0,207945</a:t>
+            </a:r>
+          </a:p>
+        </p:txBody>
+      </p:sp>
+      <p:sp>
+        <p:nvSpPr>
+          <p:cNvPr id="162" name="TextBox 161"/>
+          <p:cNvSpPr txBox="1"/>
+          <p:nvPr/>
+        </p:nvSpPr>
+        <p:spPr>
+          <a:xfrm>
+            <a:off x="960120" y="4736592"/>
+            <a:ext cx="2926080" cy="320040"/>
+          </a:xfrm>
+          <a:prstGeom prst="rect">
+            <a:avLst/>
+          </a:prstGeom>
+          <a:noFill/>
+        </p:spPr>
+        <p:txBody>
+          <a:bodyPr wrap="square" anchor="t" lIns="0" rIns="0" tIns="0" bIns="0">
+            <a:spAutoFit/>
+          </a:bodyPr>
+          <a:lstStyle/>
+          <a:p>
+            <a:pPr algn="ctr">
+              <a:spcAft>
+                <a:spcPts val="400"/>
+              </a:spcAft>
+            </a:pPr>
+            <a:r>
+              <a:rPr sz="1090" b="0" i="0">
+                <a:solidFill>
+                  <a:srgbClr val="5E6E78"/>
+                </a:solidFill>
+                <a:latin typeface="Calibri (MS)"/>
+              </a:rPr>
+              <a:t>sebelum → sesudah dibetulkan</a:t>
+            </a:r>
+          </a:p>
+        </p:txBody>
+      </p:sp>
+      <p:cxnSp>
+        <p:nvCxnSpPr>
+          <p:cNvPr id="163" name="Connector 162"/>
+          <p:cNvCxnSpPr/>
+          <p:nvPr/>
+        </p:nvCxnSpPr>
+        <p:spPr>
+          <a:xfrm>
+            <a:off x="1097280" y="5120640"/>
+            <a:ext cx="2651760" cy="0"/>
+          </a:xfrm>
+          <a:prstGeom prst="line">
+            <a:avLst/>
+          </a:prstGeom>
+          <a:ln w="12700">
+            <a:solidFill>
+              <a:srgbClr val="CFE5E9"/>
+            </a:solidFill>
+          </a:ln>
+        </p:spPr>
+        <p:style>
+          <a:lnRef idx="2">
+            <a:schemeClr val="accent1"/>
+          </a:lnRef>
+          <a:fillRef idx="0">
+            <a:schemeClr val="accent1"/>
+          </a:fillRef>
+          <a:effectRef idx="1">
+            <a:schemeClr val="accent1"/>
+          </a:effectRef>
+          <a:fontRef idx="minor">
+            <a:schemeClr val="tx1"/>
+          </a:fontRef>
+        </p:style>
+      </p:cxnSp>
+      <p:sp>
+        <p:nvSpPr>
+          <p:cNvPr id="164" name="TextBox 163"/>
+          <p:cNvSpPr txBox="1"/>
+          <p:nvPr/>
+        </p:nvSpPr>
+        <p:spPr>
+          <a:xfrm>
+            <a:off x="960120" y="5193792"/>
+            <a:ext cx="2926080" cy="1600200"/>
+          </a:xfrm>
+          <a:prstGeom prst="rect">
+            <a:avLst/>
+          </a:prstGeom>
+          <a:noFill/>
+        </p:spPr>
+        <p:txBody>
+          <a:bodyPr wrap="square" anchor="t" lIns="0" rIns="0" tIns="0" bIns="0">
+            <a:spAutoFit/>
+          </a:bodyPr>
+          <a:lstStyle/>
+          <a:p>
+            <a:pPr algn="l">
+              <a:spcAft>
+                <a:spcPts val="400"/>
+              </a:spcAft>
+            </a:pPr>
+            <a:r>
+              <a:rPr sz="1210" b="1" i="0">
+                <a:solidFill>
+                  <a:srgbClr val="0B5E6E"/>
+                </a:solidFill>
+                <a:latin typeface="Calibri (MS) Bold"/>
+              </a:rPr>
+              <a:t>Kenapa? </a:t>
             </a:r>
             <a:r>
               <a:rPr sz="1210" b="0" i="0">
@@ -6116,71 +6486,21 @@
                 </a:solidFill>
                 <a:latin typeface="Calibri (MS)"/>
               </a:rPr>
-              <a:t>Rumus untuk menghitung LPE dan LPD dicek ulang terhadap persamaan model.</a:t>
-            </a:r>
-          </a:p>
-          <a:p>
-            <a:pPr algn="l">
-              <a:spcAft>
-                <a:spcPts val="300"/>
-              </a:spcAft>
-            </a:pPr>
-            <a:r>
-              <a:rPr sz="1210" b="1" i="0">
-                <a:solidFill>
-                  <a:srgbClr val="0B5E6E"/>
-                </a:solidFill>
-                <a:latin typeface="Calibri (MS) Bold"/>
-              </a:rPr>
-              <a:t>Hasilnya:  </a:t>
-            </a:r>
-            <a:r>
-              <a:rPr sz="1210" b="0" i="0">
-                <a:solidFill>
-                  <a:srgbClr val="14313B"/>
-                </a:solidFill>
-                <a:latin typeface="Calibri (MS)"/>
-              </a:rPr>
-              <a:t>Rumus awal menganggap daya tarik 2024 bernilai 1, padahal nilainya 0,99223. Setelah dibetulkan: LPE 0,26864 → 0,27726 dan LPD 0,20148 → 0,207945.</a:t>
-            </a:r>
-          </a:p>
-          <a:p>
-            <a:pPr algn="l">
-              <a:spcAft>
-                <a:spcPts val="300"/>
-              </a:spcAft>
-            </a:pPr>
-            <a:r>
-              <a:rPr sz="1210" b="1" i="0">
-                <a:solidFill>
-                  <a:srgbClr val="0B5E6E"/>
-                </a:solidFill>
-                <a:latin typeface="Calibri (MS) Bold"/>
-              </a:rPr>
-              <a:t>Dampak:  </a:t>
-            </a:r>
-            <a:r>
-              <a:rPr sz="1210" b="0" i="0">
-                <a:solidFill>
-                  <a:srgbClr val="14313B"/>
-                </a:solidFill>
-                <a:latin typeface="Calibri (MS)"/>
-              </a:rPr>
-              <a:t>Wisatawan 2050 hanya naik sekitar 1,6%; hasil uji kondisi ekstrem tidak berubah.</a:t>
-            </a:r>
-          </a:p>
-        </p:txBody>
-      </p:sp>
-      <p:sp>
-        <p:nvSpPr>
-          <p:cNvPr id="157" name="Rounded Rectangle 156"/>
+              <a:t>Rumus awal menganggap daya tarik 2024 = 1, padahal 0,99223. Dampaknya kecil: wisatawan 2050 naik sekitar 1,6%.</a:t>
+            </a:r>
+          </a:p>
+        </p:txBody>
+      </p:sp>
+      <p:sp>
+        <p:nvSpPr>
+          <p:cNvPr id="165" name="Rounded Rectangle 164"/>
           <p:cNvSpPr/>
           <p:nvPr/>
         </p:nvSpPr>
         <p:spPr>
           <a:xfrm>
-            <a:off x="932688" y="6967728"/>
-            <a:ext cx="2980944" cy="685800"/>
+            <a:off x="932688" y="6876288"/>
+            <a:ext cx="2980944" cy="731520"/>
           </a:xfrm>
           <a:prstGeom prst="roundRect">
             <a:avLst>
@@ -6219,26 +6539,26 @@
               </a:spcAft>
             </a:pPr>
             <a:r>
-              <a:rPr sz="1150" b="1" i="0">
+              <a:rPr sz="1210" b="1" i="0">
                 <a:solidFill>
                   <a:srgbClr val="14313B"/>
                 </a:solidFill>
                 <a:latin typeface="Calibri (MS) Bold"/>
               </a:rPr>
-              <a:t>Nilai dibetulkan, bukan dicari ulang (bukan kalibrasi)</a:t>
-            </a:r>
-          </a:p>
-        </p:txBody>
-      </p:sp>
-      <p:sp>
-        <p:nvSpPr>
-          <p:cNvPr id="158" name="Right Arrow 157"/>
+              <a:t>Dibetulkan, bukan kalibrasi</a:t>
+            </a:r>
+          </a:p>
+        </p:txBody>
+      </p:sp>
+      <p:sp>
+        <p:nvSpPr>
+          <p:cNvPr id="166" name="Right Arrow 165"/>
           <p:cNvSpPr/>
           <p:nvPr/>
         </p:nvSpPr>
         <p:spPr>
           <a:xfrm>
-            <a:off x="4005072" y="4480560"/>
+            <a:off x="4005072" y="2029968"/>
             <a:ext cx="196596" cy="274320"/>
           </a:xfrm>
           <a:prstGeom prst="rightArrow">
@@ -6276,22 +6596,22 @@
       </p:sp>
       <p:sp>
         <p:nvSpPr>
-          <p:cNvPr id="159" name="Rounded Rectangle 158"/>
+          <p:cNvPr id="167" name="Rounded Rectangle 166"/>
           <p:cNvSpPr/>
           <p:nvPr/>
         </p:nvSpPr>
         <p:spPr>
           <a:xfrm>
             <a:off x="4183380" y="1783080"/>
-            <a:ext cx="3200400" cy="5989320"/>
+            <a:ext cx="3200400" cy="5943600"/>
           </a:xfrm>
           <a:prstGeom prst="roundRect">
             <a:avLst>
-              <a:gd name="adj" fmla="val 8000"/>
+              <a:gd name="adj" fmla="val 5000"/>
             </a:avLst>
           </a:prstGeom>
           <a:solidFill>
-            <a:srgbClr val="EAF8FA"/>
+            <a:srgbClr val="FFFFFF"/>
           </a:solidFill>
           <a:ln w="12700">
             <a:solidFill>
@@ -6315,7 +6635,53 @@
           </a:fontRef>
         </p:style>
         <p:txBody>
-          <a:bodyPr rtlCol="0" anchor="t" wrap="square" lIns="128016" rIns="128016" tIns="109728" bIns="109728"/>
+          <a:bodyPr rtlCol="0" anchor="t" wrap="square" lIns="164592" rIns="164592" tIns="109728" bIns="109728"/>
+          <a:lstStyle/>
+          <a:p>
+            <a:pPr algn="ctr"/>
+          </a:p>
+        </p:txBody>
+      </p:sp>
+      <p:sp>
+        <p:nvSpPr>
+          <p:cNvPr id="168" name="Rounded Rectangle 167"/>
+          <p:cNvSpPr/>
+          <p:nvPr/>
+        </p:nvSpPr>
+        <p:spPr>
+          <a:xfrm>
+            <a:off x="4183380" y="1783080"/>
+            <a:ext cx="3200400" cy="777240"/>
+          </a:xfrm>
+          <a:prstGeom prst="roundRect">
+            <a:avLst>
+              <a:gd name="adj" fmla="val 12000"/>
+            </a:avLst>
+          </a:prstGeom>
+          <a:solidFill>
+            <a:srgbClr val="0B5E6E"/>
+          </a:solidFill>
+          <a:ln>
+            <a:noFill/>
+          </a:ln>
+          <a:effectLst/>
+        </p:spPr>
+        <p:style>
+          <a:lnRef idx="1">
+            <a:schemeClr val="accent1"/>
+          </a:lnRef>
+          <a:fillRef idx="3">
+            <a:schemeClr val="accent1"/>
+          </a:fillRef>
+          <a:effectRef idx="2">
+            <a:schemeClr val="accent1"/>
+          </a:effectRef>
+          <a:fontRef idx="minor">
+            <a:schemeClr val="lt1"/>
+          </a:fontRef>
+        </p:style>
+        <p:txBody>
+          <a:bodyPr rtlCol="0" anchor="ctr" wrap="square" lIns="137160" rIns="137160" tIns="109728" bIns="109728"/>
           <a:lstStyle/>
           <a:p>
             <a:pPr algn="l">
@@ -6326,7 +6692,7 @@
             <a:r>
               <a:rPr sz="1090" b="1" i="0">
                 <a:solidFill>
-                  <a:srgbClr val="5E6E78"/>
+                  <a:srgbClr val="FFD23B"/>
                 </a:solidFill>
                 <a:latin typeface="Calibri (MS) Bold"/>
               </a:rPr>
@@ -6342,13 +6708,95 @@
             <a:r>
               <a:rPr sz="1440" b="1" i="0">
                 <a:solidFill>
-                  <a:srgbClr val="0B5E6E"/>
+                  <a:srgbClr val="FFFFFF"/>
                 </a:solidFill>
                 <a:latin typeface="Calibri (MS) Bold"/>
               </a:rPr>
               <a:t>Subsistem akomodasi</a:t>
             </a:r>
           </a:p>
+        </p:txBody>
+      </p:sp>
+      <p:sp>
+        <p:nvSpPr>
+          <p:cNvPr id="169" name="TextBox 168"/>
+          <p:cNvSpPr txBox="1"/>
+          <p:nvPr/>
+        </p:nvSpPr>
+        <p:spPr>
+          <a:xfrm>
+            <a:off x="4320540" y="2633472"/>
+            <a:ext cx="2926080" cy="548640"/>
+          </a:xfrm>
+          <a:prstGeom prst="rect">
+            <a:avLst/>
+          </a:prstGeom>
+          <a:noFill/>
+        </p:spPr>
+        <p:txBody>
+          <a:bodyPr wrap="square" anchor="t" lIns="0" rIns="0" tIns="0" bIns="0">
+            <a:spAutoFit/>
+          </a:bodyPr>
+          <a:lstStyle/>
+          <a:p>
+            <a:pPr algn="l">
+              <a:spcAft>
+                <a:spcPts val="400"/>
+              </a:spcAft>
+            </a:pPr>
+            <a:r>
+              <a:rPr sz="1090" b="1" i="1">
+                <a:solidFill>
+                  <a:srgbClr val="14313B"/>
+                </a:solidFill>
+                <a:latin typeface="Calibri (MS) Bold"/>
+              </a:rPr>
+              <a:t>Batas TPK pemicu pembangunan hotel dan laju demolisi</a:t>
+            </a:r>
+          </a:p>
+        </p:txBody>
+      </p:sp>
+      <p:sp>
+        <p:nvSpPr>
+          <p:cNvPr id="170" name="Rounded Rectangle 169"/>
+          <p:cNvSpPr/>
+          <p:nvPr/>
+        </p:nvSpPr>
+        <p:spPr>
+          <a:xfrm>
+            <a:off x="4320540" y="3200400"/>
+            <a:ext cx="2926080" cy="384048"/>
+          </a:xfrm>
+          <a:prstGeom prst="roundRect">
+            <a:avLst>
+              <a:gd name="adj" fmla="val 8000"/>
+            </a:avLst>
+          </a:prstGeom>
+          <a:solidFill>
+            <a:srgbClr val="EAF8FA"/>
+          </a:solidFill>
+          <a:ln>
+            <a:noFill/>
+          </a:ln>
+          <a:effectLst/>
+        </p:spPr>
+        <p:style>
+          <a:lnRef idx="1">
+            <a:schemeClr val="accent1"/>
+          </a:lnRef>
+          <a:fillRef idx="3">
+            <a:schemeClr val="accent1"/>
+          </a:fillRef>
+          <a:effectRef idx="2">
+            <a:schemeClr val="accent1"/>
+          </a:effectRef>
+          <a:fontRef idx="minor">
+            <a:schemeClr val="lt1"/>
+          </a:fontRef>
+        </p:style>
+        <p:txBody>
+          <a:bodyPr rtlCol="0" anchor="ctr" wrap="square" lIns="73152" rIns="73152" tIns="73152" bIns="73152"/>
+          <a:lstStyle/>
           <a:p>
             <a:pPr algn="l">
               <a:spcAft>
@@ -6356,19 +6804,180 @@
               </a:spcAft>
             </a:pPr>
             <a:r>
-              <a:rPr sz="1150" b="1" i="1">
+              <a:rPr sz="1030" b="1" i="0">
+                <a:solidFill>
+                  <a:srgbClr val="0B5E6E"/>
+                </a:solidFill>
+                <a:latin typeface="Calibri (MS) Bold"/>
+              </a:rPr>
+              <a:t>Dicoba: </a:t>
+            </a:r>
+            <a:r>
+              <a:rPr sz="1030" b="0" i="0">
+                <a:solidFill>
+                  <a:srgbClr val="14313B"/>
+                </a:solidFill>
+                <a:latin typeface="Calibri (MS)"/>
+              </a:rPr>
+              <a:t>775 pasangan nilai dicoba · uji P1</a:t>
+            </a:r>
+          </a:p>
+        </p:txBody>
+      </p:sp>
+      <p:sp>
+        <p:nvSpPr>
+          <p:cNvPr id="171" name="TextBox 170"/>
+          <p:cNvSpPr txBox="1"/>
+          <p:nvPr/>
+        </p:nvSpPr>
+        <p:spPr>
+          <a:xfrm>
+            <a:off x="4320540" y="3657600"/>
+            <a:ext cx="2926080" cy="685800"/>
+          </a:xfrm>
+          <a:prstGeom prst="rect">
+            <a:avLst/>
+          </a:prstGeom>
+          <a:noFill/>
+        </p:spPr>
+        <p:txBody>
+          <a:bodyPr wrap="square" anchor="t" lIns="0" rIns="0" tIns="0" bIns="0">
+            <a:spAutoFit/>
+          </a:bodyPr>
+          <a:lstStyle/>
+          <a:p>
+            <a:pPr algn="ctr">
+              <a:spcAft>
+                <a:spcPts val="400"/>
+              </a:spcAft>
+            </a:pPr>
+            <a:r>
+              <a:rPr sz="3220" b="1" i="0">
+                <a:solidFill>
+                  <a:srgbClr val="0B5E6E"/>
+                </a:solidFill>
+                <a:latin typeface="Calibri (MS) Bold"/>
+              </a:rPr>
+              <a:t>11,64%</a:t>
+            </a:r>
+          </a:p>
+        </p:txBody>
+      </p:sp>
+      <p:sp>
+        <p:nvSpPr>
+          <p:cNvPr id="172" name="TextBox 171"/>
+          <p:cNvSpPr txBox="1"/>
+          <p:nvPr/>
+        </p:nvSpPr>
+        <p:spPr>
+          <a:xfrm>
+            <a:off x="4320540" y="4370832"/>
+            <a:ext cx="2926080" cy="685800"/>
+          </a:xfrm>
+          <a:prstGeom prst="rect">
+            <a:avLst/>
+          </a:prstGeom>
+          <a:noFill/>
+        </p:spPr>
+        <p:txBody>
+          <a:bodyPr wrap="square" anchor="t" lIns="0" rIns="0" tIns="0" bIns="0">
+            <a:spAutoFit/>
+          </a:bodyPr>
+          <a:lstStyle/>
+          <a:p>
+            <a:pPr algn="ctr">
+              <a:spcAft>
+                <a:spcPts val="400"/>
+              </a:spcAft>
+            </a:pPr>
+            <a:r>
+              <a:rPr sz="1150" b="1" i="0">
                 <a:solidFill>
                   <a:srgbClr val="14313B"/>
                 </a:solidFill>
                 <a:latin typeface="Calibri (MS) Bold"/>
               </a:rPr>
-              <a:t>Batas TPK pemicu pembangunan hotel dan laju demolisi (hotel tutup)</a:t>
-            </a:r>
-          </a:p>
+              <a:t>lebih cocok pada nilai terbaik</a:t>
+            </a:r>
+          </a:p>
+          <a:p>
+            <a:pPr algn="ctr">
+              <a:spcAft>
+                <a:spcPts val="400"/>
+              </a:spcAft>
+            </a:pPr>
+            <a:r>
+              <a:rPr sz="1090" b="0" i="0">
+                <a:solidFill>
+                  <a:srgbClr val="5E6E78"/>
+                </a:solidFill>
+                <a:latin typeface="Calibri (MS)"/>
+              </a:rPr>
+              <a:t>→ tinggal 5,74% bila data 2019 dibuang</a:t>
+            </a:r>
+          </a:p>
+        </p:txBody>
+      </p:sp>
+      <p:cxnSp>
+        <p:nvCxnSpPr>
+          <p:cNvPr id="173" name="Connector 172"/>
+          <p:cNvCxnSpPr/>
+          <p:nvPr/>
+        </p:nvCxnSpPr>
+        <p:spPr>
+          <a:xfrm>
+            <a:off x="4457700" y="5120640"/>
+            <a:ext cx="2651759" cy="0"/>
+          </a:xfrm>
+          <a:prstGeom prst="line">
+            <a:avLst/>
+          </a:prstGeom>
+          <a:ln w="12700">
+            <a:solidFill>
+              <a:srgbClr val="CFE5E9"/>
+            </a:solidFill>
+          </a:ln>
+        </p:spPr>
+        <p:style>
+          <a:lnRef idx="2">
+            <a:schemeClr val="accent1"/>
+          </a:lnRef>
+          <a:fillRef idx="0">
+            <a:schemeClr val="accent1"/>
+          </a:fillRef>
+          <a:effectRef idx="1">
+            <a:schemeClr val="accent1"/>
+          </a:effectRef>
+          <a:fontRef idx="minor">
+            <a:schemeClr val="tx1"/>
+          </a:fontRef>
+        </p:style>
+      </p:cxnSp>
+      <p:sp>
+        <p:nvSpPr>
+          <p:cNvPr id="174" name="TextBox 173"/>
+          <p:cNvSpPr txBox="1"/>
+          <p:nvPr/>
+        </p:nvSpPr>
+        <p:spPr>
+          <a:xfrm>
+            <a:off x="4320540" y="5193792"/>
+            <a:ext cx="2926080" cy="1600200"/>
+          </a:xfrm>
+          <a:prstGeom prst="rect">
+            <a:avLst/>
+          </a:prstGeom>
+          <a:noFill/>
+        </p:spPr>
+        <p:txBody>
+          <a:bodyPr wrap="square" anchor="t" lIns="0" rIns="0" tIns="0" bIns="0">
+            <a:spAutoFit/>
+          </a:bodyPr>
+          <a:lstStyle/>
           <a:p>
             <a:pPr algn="l">
               <a:spcAft>
-                <a:spcPts val="300"/>
+                <a:spcPts val="400"/>
               </a:spcAft>
             </a:pPr>
             <a:r>
@@ -6378,7 +6987,7 @@
                 </a:solidFill>
                 <a:latin typeface="Calibri (MS) Bold"/>
               </a:rPr>
-              <a:t>Yang dilakukan:  </a:t>
+              <a:t>Kenapa? </a:t>
             </a:r>
             <a:r>
               <a:rPr sz="1210" b="0" i="0">
@@ -6387,71 +6996,21 @@
                 </a:solidFill>
                 <a:latin typeface="Calibri (MS)"/>
               </a:rPr>
-              <a:t>775 pasangan nilai dicoba (batas TPK 0,20–0,35; demolisi 0,02–0,08) dan dibandingkan dengan data hotel (uji P1).</a:t>
-            </a:r>
-          </a:p>
-          <a:p>
-            <a:pPr algn="l">
-              <a:spcAft>
-                <a:spcPts val="300"/>
-              </a:spcAft>
-            </a:pPr>
-            <a:r>
-              <a:rPr sz="1210" b="1" i="0">
-                <a:solidFill>
-                  <a:srgbClr val="0B5E6E"/>
-                </a:solidFill>
-                <a:latin typeface="Calibri (MS) Bold"/>
-              </a:rPr>
-              <a:t>Hasilnya:  </a:t>
-            </a:r>
-            <a:r>
-              <a:rPr sz="1210" b="0" i="0">
-                <a:solidFill>
-                  <a:srgbClr val="14313B"/>
-                </a:solidFill>
-                <a:latin typeface="Calibri (MS)"/>
-              </a:rPr>
-              <a:t>Pasangan terbaik (0,350; 0,060) 11,64% lebih cocok, tetapi letaknya di batas atas yang dicoba. Tanpa data 2019, keunggulannya tinggal 5,74%; pada data dengan COVID justru memburuk; pada P1b hanya 4,89%.</a:t>
-            </a:r>
-          </a:p>
-          <a:p>
-            <a:pPr algn="l">
-              <a:spcAft>
-                <a:spcPts val="300"/>
-              </a:spcAft>
-            </a:pPr>
-            <a:r>
-              <a:rPr sz="1210" b="1" i="0">
-                <a:solidFill>
-                  <a:srgbClr val="0B5E6E"/>
-                </a:solidFill>
-                <a:latin typeface="Calibri (MS) Bold"/>
-              </a:rPr>
-              <a:t>Artinya:  </a:t>
-            </a:r>
-            <a:r>
-              <a:rPr sz="1210" b="0" i="0">
-                <a:solidFill>
-                  <a:srgbClr val="14313B"/>
-                </a:solidFill>
-                <a:latin typeface="Calibri (MS)"/>
-              </a:rPr>
-              <a:t>Keunggulan nilai baru hanya muncul karena satu tahun data yang janggal.</a:t>
-            </a:r>
-          </a:p>
-        </p:txBody>
-      </p:sp>
-      <p:sp>
-        <p:nvSpPr>
-          <p:cNvPr id="160" name="Rounded Rectangle 159"/>
+              <a:t>Nilai terbaik jatuh di batas atas yang dicoba, dan keunggulannya hanya muncul karena satu tahun data yang janggal.</a:t>
+            </a:r>
+          </a:p>
+        </p:txBody>
+      </p:sp>
+      <p:sp>
+        <p:nvSpPr>
+          <p:cNvPr id="175" name="Rounded Rectangle 174"/>
           <p:cNvSpPr/>
           <p:nvPr/>
         </p:nvSpPr>
         <p:spPr>
           <a:xfrm>
-            <a:off x="4293108" y="6967728"/>
-            <a:ext cx="2980944" cy="685800"/>
+            <a:off x="4293108" y="6876288"/>
+            <a:ext cx="2980944" cy="731520"/>
           </a:xfrm>
           <a:prstGeom prst="roundRect">
             <a:avLst>
@@ -6490,26 +7049,42 @@
               </a:spcAft>
             </a:pPr>
             <a:r>
-              <a:rPr sz="1150" b="1" i="0">
+              <a:rPr sz="1210" b="1" i="0">
                 <a:solidFill>
                   <a:srgbClr val="FFFFFF"/>
                 </a:solidFill>
                 <a:latin typeface="Calibri (MS) Bold"/>
               </a:rPr>
-              <a:t>Nilai dari data tetap dipakai: batas TPK 0,275; demolisi 0,05</a:t>
-            </a:r>
-          </a:p>
-        </p:txBody>
-      </p:sp>
-      <p:sp>
-        <p:nvSpPr>
-          <p:cNvPr id="161" name="Right Arrow 160"/>
+              <a:t>Nilai dari data tetap dipakai</a:t>
+            </a:r>
+          </a:p>
+          <a:p>
+            <a:pPr algn="ctr">
+              <a:spcAft>
+                <a:spcPts val="300"/>
+              </a:spcAft>
+            </a:pPr>
+            <a:r>
+              <a:rPr sz="1090" b="0" i="0">
+                <a:solidFill>
+                  <a:srgbClr val="FFFFFF"/>
+                </a:solidFill>
+                <a:latin typeface="Calibri (MS)"/>
+              </a:rPr>
+              <a:t>(0,275 dan 0,05)</a:t>
+            </a:r>
+          </a:p>
+        </p:txBody>
+      </p:sp>
+      <p:sp>
+        <p:nvSpPr>
+          <p:cNvPr id="176" name="Right Arrow 175"/>
           <p:cNvSpPr/>
           <p:nvPr/>
         </p:nvSpPr>
         <p:spPr>
           <a:xfrm>
-            <a:off x="7365492" y="4480560"/>
+            <a:off x="7365492" y="2029968"/>
             <a:ext cx="196596" cy="274320"/>
           </a:xfrm>
           <a:prstGeom prst="rightArrow">
@@ -6547,22 +7122,22 @@
       </p:sp>
       <p:sp>
         <p:nvSpPr>
-          <p:cNvPr id="162" name="Rounded Rectangle 161"/>
+          <p:cNvPr id="177" name="Rounded Rectangle 176"/>
           <p:cNvSpPr/>
           <p:nvPr/>
         </p:nvSpPr>
         <p:spPr>
           <a:xfrm>
             <a:off x="7543800" y="1783080"/>
-            <a:ext cx="3200400" cy="5989320"/>
+            <a:ext cx="3200400" cy="5943600"/>
           </a:xfrm>
           <a:prstGeom prst="roundRect">
             <a:avLst>
-              <a:gd name="adj" fmla="val 8000"/>
+              <a:gd name="adj" fmla="val 5000"/>
             </a:avLst>
           </a:prstGeom>
           <a:solidFill>
-            <a:srgbClr val="EAF8FA"/>
+            <a:srgbClr val="FFFFFF"/>
           </a:solidFill>
           <a:ln w="12700">
             <a:solidFill>
@@ -6586,7 +7161,53 @@
           </a:fontRef>
         </p:style>
         <p:txBody>
-          <a:bodyPr rtlCol="0" anchor="t" wrap="square" lIns="128016" rIns="128016" tIns="109728" bIns="109728"/>
+          <a:bodyPr rtlCol="0" anchor="t" wrap="square" lIns="164592" rIns="164592" tIns="109728" bIns="109728"/>
+          <a:lstStyle/>
+          <a:p>
+            <a:pPr algn="ctr"/>
+          </a:p>
+        </p:txBody>
+      </p:sp>
+      <p:sp>
+        <p:nvSpPr>
+          <p:cNvPr id="178" name="Rounded Rectangle 177"/>
+          <p:cNvSpPr/>
+          <p:nvPr/>
+        </p:nvSpPr>
+        <p:spPr>
+          <a:xfrm>
+            <a:off x="7543800" y="1783080"/>
+            <a:ext cx="3200400" cy="777240"/>
+          </a:xfrm>
+          <a:prstGeom prst="roundRect">
+            <a:avLst>
+              <a:gd name="adj" fmla="val 12000"/>
+            </a:avLst>
+          </a:prstGeom>
+          <a:solidFill>
+            <a:srgbClr val="0B5E6E"/>
+          </a:solidFill>
+          <a:ln>
+            <a:noFill/>
+          </a:ln>
+          <a:effectLst/>
+        </p:spPr>
+        <p:style>
+          <a:lnRef idx="1">
+            <a:schemeClr val="accent1"/>
+          </a:lnRef>
+          <a:fillRef idx="3">
+            <a:schemeClr val="accent1"/>
+          </a:fillRef>
+          <a:effectRef idx="2">
+            <a:schemeClr val="accent1"/>
+          </a:effectRef>
+          <a:fontRef idx="minor">
+            <a:schemeClr val="lt1"/>
+          </a:fontRef>
+        </p:style>
+        <p:txBody>
+          <a:bodyPr rtlCol="0" anchor="ctr" wrap="square" lIns="137160" rIns="137160" tIns="109728" bIns="109728"/>
           <a:lstStyle/>
           <a:p>
             <a:pPr algn="l">
@@ -6597,7 +7218,7 @@
             <a:r>
               <a:rPr sz="1090" b="1" i="0">
                 <a:solidFill>
-                  <a:srgbClr val="5E6E78"/>
+                  <a:srgbClr val="FFD23B"/>
                 </a:solidFill>
                 <a:latin typeface="Calibri (MS) Bold"/>
               </a:rPr>
@@ -6613,13 +7234,95 @@
             <a:r>
               <a:rPr sz="1440" b="1" i="0">
                 <a:solidFill>
-                  <a:srgbClr val="0B5E6E"/>
+                  <a:srgbClr val="FFFFFF"/>
                 </a:solidFill>
                 <a:latin typeface="Calibri (MS) Bold"/>
               </a:rPr>
               <a:t>Subsistem lahan</a:t>
             </a:r>
           </a:p>
+        </p:txBody>
+      </p:sp>
+      <p:sp>
+        <p:nvSpPr>
+          <p:cNvPr id="179" name="TextBox 178"/>
+          <p:cNvSpPr txBox="1"/>
+          <p:nvPr/>
+        </p:nvSpPr>
+        <p:spPr>
+          <a:xfrm>
+            <a:off x="7680960" y="2633472"/>
+            <a:ext cx="2926080" cy="548640"/>
+          </a:xfrm>
+          <a:prstGeom prst="rect">
+            <a:avLst/>
+          </a:prstGeom>
+          <a:noFill/>
+        </p:spPr>
+        <p:txBody>
+          <a:bodyPr wrap="square" anchor="t" lIns="0" rIns="0" tIns="0" bIns="0">
+            <a:spAutoFit/>
+          </a:bodyPr>
+          <a:lstStyle/>
+          <a:p>
+            <a:pPr algn="l">
+              <a:spcAft>
+                <a:spcPts val="400"/>
+              </a:spcAft>
+            </a:pPr>
+            <a:r>
+              <a:rPr sz="1090" b="1" i="1">
+                <a:solidFill>
+                  <a:srgbClr val="14313B"/>
+                </a:solidFill>
+                <a:latin typeface="Calibri (MS) Bold"/>
+              </a:rPr>
+              <a:t>Laju konversi dasar (lahan menjadi lahan terbangun)</a:t>
+            </a:r>
+          </a:p>
+        </p:txBody>
+      </p:sp>
+      <p:sp>
+        <p:nvSpPr>
+          <p:cNvPr id="180" name="Rounded Rectangle 179"/>
+          <p:cNvSpPr/>
+          <p:nvPr/>
+        </p:nvSpPr>
+        <p:spPr>
+          <a:xfrm>
+            <a:off x="7680960" y="3200400"/>
+            <a:ext cx="2926080" cy="384048"/>
+          </a:xfrm>
+          <a:prstGeom prst="roundRect">
+            <a:avLst>
+              <a:gd name="adj" fmla="val 8000"/>
+            </a:avLst>
+          </a:prstGeom>
+          <a:solidFill>
+            <a:srgbClr val="EAF8FA"/>
+          </a:solidFill>
+          <a:ln>
+            <a:noFill/>
+          </a:ln>
+          <a:effectLst/>
+        </p:spPr>
+        <p:style>
+          <a:lnRef idx="1">
+            <a:schemeClr val="accent1"/>
+          </a:lnRef>
+          <a:fillRef idx="3">
+            <a:schemeClr val="accent1"/>
+          </a:fillRef>
+          <a:effectRef idx="2">
+            <a:schemeClr val="accent1"/>
+          </a:effectRef>
+          <a:fontRef idx="minor">
+            <a:schemeClr val="lt1"/>
+          </a:fontRef>
+        </p:style>
+        <p:txBody>
+          <a:bodyPr rtlCol="0" anchor="ctr" wrap="square" lIns="73152" rIns="73152" tIns="73152" bIns="73152"/>
+          <a:lstStyle/>
           <a:p>
             <a:pPr algn="l">
               <a:spcAft>
@@ -6627,19 +7330,180 @@
               </a:spcAft>
             </a:pPr>
             <a:r>
-              <a:rPr sz="1150" b="1" i="1">
+              <a:rPr sz="1030" b="1" i="0">
+                <a:solidFill>
+                  <a:srgbClr val="0B5E6E"/>
+                </a:solidFill>
+                <a:latin typeface="Calibri (MS) Bold"/>
+              </a:rPr>
+              <a:t>Dicoba: </a:t>
+            </a:r>
+            <a:r>
+              <a:rPr sz="1030" b="0" i="0">
+                <a:solidFill>
+                  <a:srgbClr val="14313B"/>
+                </a:solidFill>
+                <a:latin typeface="Calibri (MS)"/>
+              </a:rPr>
+              <a:t>Nilai 0,0034–0,0851 dicoba · uji P4</a:t>
+            </a:r>
+          </a:p>
+        </p:txBody>
+      </p:sp>
+      <p:sp>
+        <p:nvSpPr>
+          <p:cNvPr id="181" name="TextBox 180"/>
+          <p:cNvSpPr txBox="1"/>
+          <p:nvPr/>
+        </p:nvSpPr>
+        <p:spPr>
+          <a:xfrm>
+            <a:off x="7680960" y="3657600"/>
+            <a:ext cx="2926080" cy="685800"/>
+          </a:xfrm>
+          <a:prstGeom prst="rect">
+            <a:avLst/>
+          </a:prstGeom>
+          <a:noFill/>
+        </p:spPr>
+        <p:txBody>
+          <a:bodyPr wrap="square" anchor="t" lIns="0" rIns="0" tIns="0" bIns="0">
+            <a:spAutoFit/>
+          </a:bodyPr>
+          <a:lstStyle/>
+          <a:p>
+            <a:pPr algn="ctr">
+              <a:spcAft>
+                <a:spcPts val="400"/>
+              </a:spcAft>
+            </a:pPr>
+            <a:r>
+              <a:rPr sz="3220" b="1" i="0">
+                <a:solidFill>
+                  <a:srgbClr val="0B5E6E"/>
+                </a:solidFill>
+                <a:latin typeface="Calibri (MS) Bold"/>
+              </a:rPr>
+              <a:t>14,76%</a:t>
+            </a:r>
+          </a:p>
+        </p:txBody>
+      </p:sp>
+      <p:sp>
+        <p:nvSpPr>
+          <p:cNvPr id="182" name="TextBox 181"/>
+          <p:cNvSpPr txBox="1"/>
+          <p:nvPr/>
+        </p:nvSpPr>
+        <p:spPr>
+          <a:xfrm>
+            <a:off x="7680960" y="4370832"/>
+            <a:ext cx="2926080" cy="685800"/>
+          </a:xfrm>
+          <a:prstGeom prst="rect">
+            <a:avLst/>
+          </a:prstGeom>
+          <a:noFill/>
+        </p:spPr>
+        <p:txBody>
+          <a:bodyPr wrap="square" anchor="t" lIns="0" rIns="0" tIns="0" bIns="0">
+            <a:spAutoFit/>
+          </a:bodyPr>
+          <a:lstStyle/>
+          <a:p>
+            <a:pPr algn="ctr">
+              <a:spcAft>
+                <a:spcPts val="400"/>
+              </a:spcAft>
+            </a:pPr>
+            <a:r>
+              <a:rPr sz="1150" b="1" i="0">
                 <a:solidFill>
                   <a:srgbClr val="14313B"/>
                 </a:solidFill>
                 <a:latin typeface="Calibri (MS) Bold"/>
               </a:rPr>
-              <a:t>Laju konversi dasar (laju lahan berubah menjadi lahan terbangun)</a:t>
-            </a:r>
-          </a:p>
+              <a:t>lebih cocok pada nilai 0,0639</a:t>
+            </a:r>
+          </a:p>
+          <a:p>
+            <a:pPr algn="ctr">
+              <a:spcAft>
+                <a:spcPts val="400"/>
+              </a:spcAft>
+            </a:pPr>
+            <a:r>
+              <a:rPr sz="1090" b="0" i="0">
+                <a:solidFill>
+                  <a:srgbClr val="5E6E78"/>
+                </a:solidFill>
+                <a:latin typeface="Calibri (MS)"/>
+              </a:rPr>
+              <a:t>selisih rata-rata (U1): 0,4250 → 0,0755</a:t>
+            </a:r>
+          </a:p>
+        </p:txBody>
+      </p:sp>
+      <p:cxnSp>
+        <p:nvCxnSpPr>
+          <p:cNvPr id="183" name="Connector 182"/>
+          <p:cNvCxnSpPr/>
+          <p:nvPr/>
+        </p:nvCxnSpPr>
+        <p:spPr>
+          <a:xfrm>
+            <a:off x="7818120" y="5120640"/>
+            <a:ext cx="2651760" cy="0"/>
+          </a:xfrm>
+          <a:prstGeom prst="line">
+            <a:avLst/>
+          </a:prstGeom>
+          <a:ln w="12700">
+            <a:solidFill>
+              <a:srgbClr val="CFE5E9"/>
+            </a:solidFill>
+          </a:ln>
+        </p:spPr>
+        <p:style>
+          <a:lnRef idx="2">
+            <a:schemeClr val="accent1"/>
+          </a:lnRef>
+          <a:fillRef idx="0">
+            <a:schemeClr val="accent1"/>
+          </a:fillRef>
+          <a:effectRef idx="1">
+            <a:schemeClr val="accent1"/>
+          </a:effectRef>
+          <a:fontRef idx="minor">
+            <a:schemeClr val="tx1"/>
+          </a:fontRef>
+        </p:style>
+      </p:cxnSp>
+      <p:sp>
+        <p:nvSpPr>
+          <p:cNvPr id="184" name="TextBox 183"/>
+          <p:cNvSpPr txBox="1"/>
+          <p:nvPr/>
+        </p:nvSpPr>
+        <p:spPr>
+          <a:xfrm>
+            <a:off x="7680960" y="5193792"/>
+            <a:ext cx="2926080" cy="1600200"/>
+          </a:xfrm>
+          <a:prstGeom prst="rect">
+            <a:avLst/>
+          </a:prstGeom>
+          <a:noFill/>
+        </p:spPr>
+        <p:txBody>
+          <a:bodyPr wrap="square" anchor="t" lIns="0" rIns="0" tIns="0" bIns="0">
+            <a:spAutoFit/>
+          </a:bodyPr>
+          <a:lstStyle/>
           <a:p>
             <a:pPr algn="l">
               <a:spcAft>
-                <a:spcPts val="300"/>
+                <a:spcPts val="400"/>
               </a:spcAft>
             </a:pPr>
             <a:r>
@@ -6649,7 +7513,7 @@
                 </a:solidFill>
                 <a:latin typeface="Calibri (MS) Bold"/>
               </a:rPr>
-              <a:t>Yang dilakukan:  </a:t>
+              <a:t>Kenapa? </a:t>
             </a:r>
             <a:r>
               <a:rPr sz="1210" b="0" i="0">
@@ -6658,71 +7522,21 @@
                 </a:solidFill>
                 <a:latin typeface="Calibri (MS)"/>
               </a:rPr>
-              <a:t>Nilai 0,0034–0,0851 dicoba dan dibandingkan dengan data lahan terbangun (uji P4).</a:t>
-            </a:r>
-          </a:p>
-          <a:p>
-            <a:pPr algn="l">
-              <a:spcAft>
-                <a:spcPts val="300"/>
-              </a:spcAft>
-            </a:pPr>
-            <a:r>
-              <a:rPr sz="1210" b="1" i="0">
-                <a:solidFill>
-                  <a:srgbClr val="0B5E6E"/>
-                </a:solidFill>
-                <a:latin typeface="Calibri (MS) Bold"/>
-              </a:rPr>
-              <a:t>Hasilnya:  </a:t>
-            </a:r>
-            <a:r>
-              <a:rPr sz="1210" b="0" i="0">
-                <a:solidFill>
-                  <a:srgbClr val="14313B"/>
-                </a:solidFill>
-                <a:latin typeface="Calibri (MS)"/>
-              </a:rPr>
-              <a:t>Nilai 0,0639 14,76% lebih cocok dan letaknya di tengah, bukan di tepi. Selisih rata-rata simulasi dan data (U1) turun dari 0,4250 ke 0,0755.</a:t>
-            </a:r>
-          </a:p>
-          <a:p>
-            <a:pPr algn="l">
-              <a:spcAft>
-                <a:spcPts val="300"/>
-              </a:spcAft>
-            </a:pPr>
-            <a:r>
-              <a:rPr sz="1210" b="1" i="0">
-                <a:solidFill>
-                  <a:srgbClr val="0B5E6E"/>
-                </a:solidFill>
-                <a:latin typeface="Calibri (MS) Bold"/>
-              </a:rPr>
-              <a:t>Artinya:  </a:t>
-            </a:r>
-            <a:r>
-              <a:rPr sz="1210" b="0" i="0">
-                <a:solidFill>
-                  <a:srgbClr val="14313B"/>
-                </a:solidFill>
-                <a:latin typeface="Calibri (MS)"/>
-              </a:rPr>
-              <a:t>Memenuhi syarat dipakai (R4), tetapi harus diuji dulu pada model penuh (Tahap 4).</a:t>
-            </a:r>
-          </a:p>
-        </p:txBody>
-      </p:sp>
-      <p:sp>
-        <p:nvSpPr>
-          <p:cNvPr id="163" name="Rounded Rectangle 162"/>
+              <a:t>Letaknya di tengah, bukan di tepi, sehingga memenuhi syarat (R4). Namun masih harus diuji pada model penuh.</a:t>
+            </a:r>
+          </a:p>
+        </p:txBody>
+      </p:sp>
+      <p:sp>
+        <p:nvSpPr>
+          <p:cNvPr id="185" name="Rounded Rectangle 184"/>
           <p:cNvSpPr/>
           <p:nvPr/>
         </p:nvSpPr>
         <p:spPr>
           <a:xfrm>
-            <a:off x="7653527" y="6967728"/>
-            <a:ext cx="2980944" cy="685800"/>
+            <a:off x="7653527" y="6876288"/>
+            <a:ext cx="2980944" cy="731520"/>
           </a:xfrm>
           <a:prstGeom prst="roundRect">
             <a:avLst>
@@ -6761,26 +7575,42 @@
               </a:spcAft>
             </a:pPr>
             <a:r>
-              <a:rPr sz="1150" b="1" i="0">
+              <a:rPr sz="1210" b="1" i="0">
                 <a:solidFill>
                   <a:srgbClr val="14313B"/>
                 </a:solidFill>
                 <a:latin typeface="Calibri (MS) Bold"/>
               </a:rPr>
-              <a:t>Diterima sementara: 0,0639, lalu diuji di Tahap 4</a:t>
-            </a:r>
-          </a:p>
-        </p:txBody>
-      </p:sp>
-      <p:sp>
-        <p:nvSpPr>
-          <p:cNvPr id="164" name="Right Arrow 163"/>
+              <a:t>Diterima sementara</a:t>
+            </a:r>
+          </a:p>
+          <a:p>
+            <a:pPr algn="ctr">
+              <a:spcAft>
+                <a:spcPts val="300"/>
+              </a:spcAft>
+            </a:pPr>
+            <a:r>
+              <a:rPr sz="1090" b="0" i="0">
+                <a:solidFill>
+                  <a:srgbClr val="14313B"/>
+                </a:solidFill>
+                <a:latin typeface="Calibri (MS)"/>
+              </a:rPr>
+              <a:t>(0,0639 → diuji di Tahap 4)</a:t>
+            </a:r>
+          </a:p>
+        </p:txBody>
+      </p:sp>
+      <p:sp>
+        <p:nvSpPr>
+          <p:cNvPr id="186" name="Right Arrow 185"/>
           <p:cNvSpPr/>
           <p:nvPr/>
         </p:nvSpPr>
         <p:spPr>
           <a:xfrm>
-            <a:off x="10725912" y="4480560"/>
+            <a:off x="10725912" y="2029968"/>
             <a:ext cx="196596" cy="274320"/>
           </a:xfrm>
           <a:prstGeom prst="rightArrow">
@@ -6818,22 +7648,22 @@
       </p:sp>
       <p:sp>
         <p:nvSpPr>
-          <p:cNvPr id="165" name="Rounded Rectangle 164"/>
+          <p:cNvPr id="187" name="Rounded Rectangle 186"/>
           <p:cNvSpPr/>
           <p:nvPr/>
         </p:nvSpPr>
         <p:spPr>
           <a:xfrm>
             <a:off x="10904219" y="1783080"/>
-            <a:ext cx="3200400" cy="5989320"/>
+            <a:ext cx="3200400" cy="5943600"/>
           </a:xfrm>
           <a:prstGeom prst="roundRect">
             <a:avLst>
-              <a:gd name="adj" fmla="val 8000"/>
+              <a:gd name="adj" fmla="val 5000"/>
             </a:avLst>
           </a:prstGeom>
           <a:solidFill>
-            <a:srgbClr val="EAF8FA"/>
+            <a:srgbClr val="FFFFFF"/>
           </a:solidFill>
           <a:ln w="12700">
             <a:solidFill>
@@ -6857,7 +7687,53 @@
           </a:fontRef>
         </p:style>
         <p:txBody>
-          <a:bodyPr rtlCol="0" anchor="t" wrap="square" lIns="128016" rIns="128016" tIns="109728" bIns="109728"/>
+          <a:bodyPr rtlCol="0" anchor="t" wrap="square" lIns="164592" rIns="164592" tIns="109728" bIns="109728"/>
+          <a:lstStyle/>
+          <a:p>
+            <a:pPr algn="ctr"/>
+          </a:p>
+        </p:txBody>
+      </p:sp>
+      <p:sp>
+        <p:nvSpPr>
+          <p:cNvPr id="188" name="Rounded Rectangle 187"/>
+          <p:cNvSpPr/>
+          <p:nvPr/>
+        </p:nvSpPr>
+        <p:spPr>
+          <a:xfrm>
+            <a:off x="10904219" y="1783080"/>
+            <a:ext cx="3200400" cy="777240"/>
+          </a:xfrm>
+          <a:prstGeom prst="roundRect">
+            <a:avLst>
+              <a:gd name="adj" fmla="val 12000"/>
+            </a:avLst>
+          </a:prstGeom>
+          <a:solidFill>
+            <a:srgbClr val="0B5E6E"/>
+          </a:solidFill>
+          <a:ln>
+            <a:noFill/>
+          </a:ln>
+          <a:effectLst/>
+        </p:spPr>
+        <p:style>
+          <a:lnRef idx="1">
+            <a:schemeClr val="accent1"/>
+          </a:lnRef>
+          <a:fillRef idx="3">
+            <a:schemeClr val="accent1"/>
+          </a:fillRef>
+          <a:effectRef idx="2">
+            <a:schemeClr val="accent1"/>
+          </a:effectRef>
+          <a:fontRef idx="minor">
+            <a:schemeClr val="lt1"/>
+          </a:fontRef>
+        </p:style>
+        <p:txBody>
+          <a:bodyPr rtlCol="0" anchor="ctr" wrap="square" lIns="137160" rIns="137160" tIns="109728" bIns="109728"/>
           <a:lstStyle/>
           <a:p>
             <a:pPr algn="l">
@@ -6868,7 +7744,7 @@
             <a:r>
               <a:rPr sz="1090" b="1" i="0">
                 <a:solidFill>
-                  <a:srgbClr val="5E6E78"/>
+                  <a:srgbClr val="FFD23B"/>
                 </a:solidFill>
                 <a:latin typeface="Calibri (MS) Bold"/>
               </a:rPr>
@@ -6884,21 +7760,44 @@
             <a:r>
               <a:rPr sz="1440" b="1" i="0">
                 <a:solidFill>
-                  <a:srgbClr val="0B5E6E"/>
+                  <a:srgbClr val="FFFFFF"/>
                 </a:solidFill>
                 <a:latin typeface="Calibri (MS) Bold"/>
               </a:rPr>
               <a:t>Subsistem wisatawan</a:t>
             </a:r>
           </a:p>
+        </p:txBody>
+      </p:sp>
+      <p:sp>
+        <p:nvSpPr>
+          <p:cNvPr id="189" name="TextBox 188"/>
+          <p:cNvSpPr txBox="1"/>
+          <p:nvPr/>
+        </p:nvSpPr>
+        <p:spPr>
+          <a:xfrm>
+            <a:off x="11041380" y="2633472"/>
+            <a:ext cx="2926080" cy="548640"/>
+          </a:xfrm>
+          <a:prstGeom prst="rect">
+            <a:avLst/>
+          </a:prstGeom>
+          <a:noFill/>
+        </p:spPr>
+        <p:txBody>
+          <a:bodyPr wrap="square" anchor="t" lIns="0" rIns="0" tIns="0" bIns="0">
+            <a:spAutoFit/>
+          </a:bodyPr>
+          <a:lstStyle/>
           <a:p>
             <a:pPr algn="l">
               <a:spcAft>
-                <a:spcPts val="300"/>
+                <a:spcPts val="400"/>
               </a:spcAft>
             </a:pPr>
             <a:r>
-              <a:rPr sz="1150" b="1" i="1">
+              <a:rPr sz="1090" b="1" i="1">
                 <a:solidFill>
                   <a:srgbClr val="14313B"/>
                 </a:solidFill>
@@ -6907,10 +7806,230 @@
               <a:t>LPE dan LPD (hanya diperiksa, tidak dikalibrasi)</a:t>
             </a:r>
           </a:p>
+        </p:txBody>
+      </p:sp>
+      <p:sp>
+        <p:nvSpPr>
+          <p:cNvPr id="190" name="Rounded Rectangle 189"/>
+          <p:cNvSpPr/>
+          <p:nvPr/>
+        </p:nvSpPr>
+        <p:spPr>
+          <a:xfrm>
+            <a:off x="11041380" y="3200400"/>
+            <a:ext cx="2926080" cy="384048"/>
+          </a:xfrm>
+          <a:prstGeom prst="roundRect">
+            <a:avLst>
+              <a:gd name="adj" fmla="val 8000"/>
+            </a:avLst>
+          </a:prstGeom>
+          <a:solidFill>
+            <a:srgbClr val="EAF8FA"/>
+          </a:solidFill>
+          <a:ln>
+            <a:noFill/>
+          </a:ln>
+          <a:effectLst/>
+        </p:spPr>
+        <p:style>
+          <a:lnRef idx="1">
+            <a:schemeClr val="accent1"/>
+          </a:lnRef>
+          <a:fillRef idx="3">
+            <a:schemeClr val="accent1"/>
+          </a:fillRef>
+          <a:effectRef idx="2">
+            <a:schemeClr val="accent1"/>
+          </a:effectRef>
+          <a:fontRef idx="minor">
+            <a:schemeClr val="lt1"/>
+          </a:fontRef>
+        </p:style>
+        <p:txBody>
+          <a:bodyPr rtlCol="0" anchor="ctr" wrap="square" lIns="73152" rIns="73152" tIns="73152" bIns="73152"/>
+          <a:lstStyle/>
           <a:p>
             <a:pPr algn="l">
               <a:spcAft>
                 <a:spcPts val="300"/>
+              </a:spcAft>
+            </a:pPr>
+            <a:r>
+              <a:rPr sz="1030" b="1" i="0">
+                <a:solidFill>
+                  <a:srgbClr val="0B5E6E"/>
+                </a:solidFill>
+                <a:latin typeface="Calibri (MS) Bold"/>
+              </a:rPr>
+              <a:t>Dicoba: </a:t>
+            </a:r>
+            <a:r>
+              <a:rPr sz="1030" b="0" i="0">
+                <a:solidFill>
+                  <a:srgbClr val="14313B"/>
+                </a:solidFill>
+                <a:latin typeface="Calibri (MS)"/>
+              </a:rPr>
+              <a:t>Berapa LPE yang diminta data?</a:t>
+            </a:r>
+          </a:p>
+        </p:txBody>
+      </p:sp>
+      <p:sp>
+        <p:nvSpPr>
+          <p:cNvPr id="191" name="TextBox 190"/>
+          <p:cNvSpPr txBox="1"/>
+          <p:nvPr/>
+        </p:nvSpPr>
+        <p:spPr>
+          <a:xfrm>
+            <a:off x="11041380" y="3657600"/>
+            <a:ext cx="2926080" cy="685800"/>
+          </a:xfrm>
+          <a:prstGeom prst="rect">
+            <a:avLst/>
+          </a:prstGeom>
+          <a:noFill/>
+        </p:spPr>
+        <p:txBody>
+          <a:bodyPr wrap="square" anchor="t" lIns="0" rIns="0" tIns="0" bIns="0">
+            <a:spAutoFit/>
+          </a:bodyPr>
+          <a:lstStyle/>
+          <a:p>
+            <a:pPr algn="ctr">
+              <a:spcAft>
+                <a:spcPts val="400"/>
+              </a:spcAft>
+            </a:pPr>
+            <a:r>
+              <a:rPr sz="3220" b="1" i="0">
+                <a:solidFill>
+                  <a:srgbClr val="0B5E6E"/>
+                </a:solidFill>
+                <a:latin typeface="Calibri (MS) Bold"/>
+              </a:rPr>
+              <a:t>0,41–0,49</a:t>
+            </a:r>
+          </a:p>
+        </p:txBody>
+      </p:sp>
+      <p:sp>
+        <p:nvSpPr>
+          <p:cNvPr id="192" name="TextBox 191"/>
+          <p:cNvSpPr txBox="1"/>
+          <p:nvPr/>
+        </p:nvSpPr>
+        <p:spPr>
+          <a:xfrm>
+            <a:off x="11041380" y="4370832"/>
+            <a:ext cx="2926080" cy="685800"/>
+          </a:xfrm>
+          <a:prstGeom prst="rect">
+            <a:avLst/>
+          </a:prstGeom>
+          <a:noFill/>
+        </p:spPr>
+        <p:txBody>
+          <a:bodyPr wrap="square" anchor="t" lIns="0" rIns="0" tIns="0" bIns="0">
+            <a:spAutoFit/>
+          </a:bodyPr>
+          <a:lstStyle/>
+          <a:p>
+            <a:pPr algn="ctr">
+              <a:spcAft>
+                <a:spcPts val="400"/>
+              </a:spcAft>
+            </a:pPr>
+            <a:r>
+              <a:rPr sz="1150" b="1" i="0">
+                <a:solidFill>
+                  <a:srgbClr val="14313B"/>
+                </a:solidFill>
+                <a:latin typeface="Calibri (MS) Bold"/>
+              </a:rPr>
+              <a:t>LPE yang diminta data</a:t>
+            </a:r>
+          </a:p>
+          <a:p>
+            <a:pPr algn="ctr">
+              <a:spcAft>
+                <a:spcPts val="400"/>
+              </a:spcAft>
+            </a:pPr>
+            <a:r>
+              <a:rPr sz="1090" b="0" i="0">
+                <a:solidFill>
+                  <a:srgbClr val="5E6E78"/>
+                </a:solidFill>
+                <a:latin typeface="Calibri (MS)"/>
+              </a:rPr>
+              <a:t>nilai dari data: 0,27726</a:t>
+            </a:r>
+          </a:p>
+        </p:txBody>
+      </p:sp>
+      <p:cxnSp>
+        <p:nvCxnSpPr>
+          <p:cNvPr id="193" name="Connector 192"/>
+          <p:cNvCxnSpPr/>
+          <p:nvPr/>
+        </p:nvCxnSpPr>
+        <p:spPr>
+          <a:xfrm>
+            <a:off x="11178540" y="5120640"/>
+            <a:ext cx="2651759" cy="0"/>
+          </a:xfrm>
+          <a:prstGeom prst="line">
+            <a:avLst/>
+          </a:prstGeom>
+          <a:ln w="12700">
+            <a:solidFill>
+              <a:srgbClr val="CFE5E9"/>
+            </a:solidFill>
+          </a:ln>
+        </p:spPr>
+        <p:style>
+          <a:lnRef idx="2">
+            <a:schemeClr val="accent1"/>
+          </a:lnRef>
+          <a:fillRef idx="0">
+            <a:schemeClr val="accent1"/>
+          </a:fillRef>
+          <a:effectRef idx="1">
+            <a:schemeClr val="accent1"/>
+          </a:effectRef>
+          <a:fontRef idx="minor">
+            <a:schemeClr val="tx1"/>
+          </a:fontRef>
+        </p:style>
+      </p:cxnSp>
+      <p:sp>
+        <p:nvSpPr>
+          <p:cNvPr id="194" name="TextBox 193"/>
+          <p:cNvSpPr txBox="1"/>
+          <p:nvPr/>
+        </p:nvSpPr>
+        <p:spPr>
+          <a:xfrm>
+            <a:off x="11041380" y="5193792"/>
+            <a:ext cx="2926080" cy="1600200"/>
+          </a:xfrm>
+          <a:prstGeom prst="rect">
+            <a:avLst/>
+          </a:prstGeom>
+          <a:noFill/>
+        </p:spPr>
+        <p:txBody>
+          <a:bodyPr wrap="square" anchor="t" lIns="0" rIns="0" tIns="0" bIns="0">
+            <a:spAutoFit/>
+          </a:bodyPr>
+          <a:lstStyle/>
+          <a:p>
+            <a:pPr algn="l">
+              <a:spcAft>
+                <a:spcPts val="400"/>
               </a:spcAft>
             </a:pPr>
             <a:r>
@@ -6920,7 +8039,7 @@
                 </a:solidFill>
                 <a:latin typeface="Calibri (MS) Bold"/>
               </a:rPr>
-              <a:t>Yang dilakukan:  </a:t>
+              <a:t>Kenapa? </a:t>
             </a:r>
             <a:r>
               <a:rPr sz="1210" b="0" i="0">
@@ -6929,71 +8048,21 @@
                 </a:solidFill>
                 <a:latin typeface="Calibri (MS)"/>
               </a:rPr>
-              <a:t>Tidak dicari nilai terbaik karena keduanya tidak memenuhi syarat dikalibrasi; hanya dihitung berapa LPE yang diminta data.</a:t>
-            </a:r>
-          </a:p>
-          <a:p>
-            <a:pPr algn="l">
-              <a:spcAft>
-                <a:spcPts val="300"/>
-              </a:spcAft>
-            </a:pPr>
-            <a:r>
-              <a:rPr sz="1210" b="1" i="0">
-                <a:solidFill>
-                  <a:srgbClr val="0B5E6E"/>
-                </a:solidFill>
-                <a:latin typeface="Calibri (MS) Bold"/>
-              </a:rPr>
-              <a:t>Hasilnya:  </a:t>
-            </a:r>
-            <a:r>
-              <a:rPr sz="1210" b="0" i="0">
-                <a:solidFill>
-                  <a:srgbClr val="14313B"/>
-                </a:solidFill>
-                <a:latin typeface="Calibri (MS)"/>
-              </a:rPr>
-              <a:t>Data meminta LPE 0,410–0,490 (nilai dari data 0,27726). Namun banyak pasangan LPE–LPD yang sama cocoknya, jadi data hanya bisa menentukan selisih keduanya, bukan masing-masing nilai.</a:t>
-            </a:r>
-          </a:p>
-          <a:p>
-            <a:pPr algn="l">
-              <a:spcAft>
-                <a:spcPts val="300"/>
-              </a:spcAft>
-            </a:pPr>
-            <a:r>
-              <a:rPr sz="1210" b="1" i="0">
-                <a:solidFill>
-                  <a:srgbClr val="0B5E6E"/>
-                </a:solidFill>
-                <a:latin typeface="Calibri (MS) Bold"/>
-              </a:rPr>
-              <a:t>Penyebab:  </a:t>
-            </a:r>
-            <a:r>
-              <a:rPr sz="1210" b="0" i="0">
-                <a:solidFill>
-                  <a:srgbClr val="14313B"/>
-                </a:solidFill>
-                <a:latin typeface="Calibri (MS)"/>
-              </a:rPr>
-              <a:t>Wisatawan melonjak setelah pandemi (2022–2024, puncak 24,86% per tahun), hal yang tidak dimodelkan.</a:t>
-            </a:r>
-          </a:p>
-        </p:txBody>
-      </p:sp>
-      <p:sp>
-        <p:nvSpPr>
-          <p:cNvPr id="166" name="Rounded Rectangle 165"/>
+              <a:t>Banyak pasangan LPE–LPD sama cocoknya, jadi data hanya bisa menentukan selisih keduanya. Penyebab: lonjakan wisatawan setelah pandemi (puncak 24,86% pada 2024).</a:t>
+            </a:r>
+          </a:p>
+        </p:txBody>
+      </p:sp>
+      <p:sp>
+        <p:nvSpPr>
+          <p:cNvPr id="195" name="Rounded Rectangle 194"/>
           <p:cNvSpPr/>
           <p:nvPr/>
         </p:nvSpPr>
         <p:spPr>
           <a:xfrm>
-            <a:off x="11013947" y="6967728"/>
-            <a:ext cx="2980944" cy="685800"/>
+            <a:off x="11013947" y="6876288"/>
+            <a:ext cx="2980944" cy="731520"/>
           </a:xfrm>
           <a:prstGeom prst="roundRect">
             <a:avLst>
@@ -7032,26 +8101,42 @@
               </a:spcAft>
             </a:pPr>
             <a:r>
-              <a:rPr sz="1150" b="1" i="0">
+              <a:rPr sz="1210" b="1" i="0">
                 <a:solidFill>
                   <a:srgbClr val="FFFFFF"/>
                 </a:solidFill>
                 <a:latin typeface="Calibri (MS) Bold"/>
               </a:rPr>
-              <a:t>Nilai dari data tetap dipakai: LPE 0,27726; LPD 0,207945</a:t>
-            </a:r>
-          </a:p>
-        </p:txBody>
-      </p:sp>
-      <p:sp>
-        <p:nvSpPr>
-          <p:cNvPr id="167" name="Right Arrow 166"/>
+              <a:t>Nilai dari data tetap dipakai</a:t>
+            </a:r>
+          </a:p>
+          <a:p>
+            <a:pPr algn="ctr">
+              <a:spcAft>
+                <a:spcPts val="300"/>
+              </a:spcAft>
+            </a:pPr>
+            <a:r>
+              <a:rPr sz="1090" b="0" i="0">
+                <a:solidFill>
+                  <a:srgbClr val="FFFFFF"/>
+                </a:solidFill>
+                <a:latin typeface="Calibri (MS)"/>
+              </a:rPr>
+              <a:t>(0,27726 dan 0,207945)</a:t>
+            </a:r>
+          </a:p>
+        </p:txBody>
+      </p:sp>
+      <p:sp>
+        <p:nvSpPr>
+          <p:cNvPr id="196" name="Right Arrow 195"/>
           <p:cNvSpPr/>
           <p:nvPr/>
         </p:nvSpPr>
         <p:spPr>
           <a:xfrm>
-            <a:off x="14086332" y="4480560"/>
+            <a:off x="14086332" y="2029968"/>
             <a:ext cx="196596" cy="274320"/>
           </a:xfrm>
           <a:prstGeom prst="rightArrow">
@@ -7089,22 +8174,22 @@
       </p:sp>
       <p:sp>
         <p:nvSpPr>
-          <p:cNvPr id="168" name="Rounded Rectangle 167"/>
+          <p:cNvPr id="197" name="Rounded Rectangle 196"/>
           <p:cNvSpPr/>
           <p:nvPr/>
         </p:nvSpPr>
         <p:spPr>
           <a:xfrm>
             <a:off x="14264640" y="1783080"/>
-            <a:ext cx="3200400" cy="5989320"/>
+            <a:ext cx="3200400" cy="5943600"/>
           </a:xfrm>
           <a:prstGeom prst="roundRect">
             <a:avLst>
-              <a:gd name="adj" fmla="val 8000"/>
+              <a:gd name="adj" fmla="val 5000"/>
             </a:avLst>
           </a:prstGeom>
           <a:solidFill>
-            <a:srgbClr val="EAF8FA"/>
+            <a:srgbClr val="FFFFFF"/>
           </a:solidFill>
           <a:ln w="12700">
             <a:solidFill>
@@ -7128,7 +8213,53 @@
           </a:fontRef>
         </p:style>
         <p:txBody>
-          <a:bodyPr rtlCol="0" anchor="t" wrap="square" lIns="128016" rIns="128016" tIns="109728" bIns="109728"/>
+          <a:bodyPr rtlCol="0" anchor="t" wrap="square" lIns="164592" rIns="164592" tIns="109728" bIns="109728"/>
+          <a:lstStyle/>
+          <a:p>
+            <a:pPr algn="ctr"/>
+          </a:p>
+        </p:txBody>
+      </p:sp>
+      <p:sp>
+        <p:nvSpPr>
+          <p:cNvPr id="198" name="Rounded Rectangle 197"/>
+          <p:cNvSpPr/>
+          <p:nvPr/>
+        </p:nvSpPr>
+        <p:spPr>
+          <a:xfrm>
+            <a:off x="14264640" y="1783080"/>
+            <a:ext cx="3200400" cy="777240"/>
+          </a:xfrm>
+          <a:prstGeom prst="roundRect">
+            <a:avLst>
+              <a:gd name="adj" fmla="val 12000"/>
+            </a:avLst>
+          </a:prstGeom>
+          <a:solidFill>
+            <a:srgbClr val="E4604F"/>
+          </a:solidFill>
+          <a:ln>
+            <a:noFill/>
+          </a:ln>
+          <a:effectLst/>
+        </p:spPr>
+        <p:style>
+          <a:lnRef idx="1">
+            <a:schemeClr val="accent1"/>
+          </a:lnRef>
+          <a:fillRef idx="3">
+            <a:schemeClr val="accent1"/>
+          </a:fillRef>
+          <a:effectRef idx="2">
+            <a:schemeClr val="accent1"/>
+          </a:effectRef>
+          <a:fontRef idx="minor">
+            <a:schemeClr val="lt1"/>
+          </a:fontRef>
+        </p:style>
+        <p:txBody>
+          <a:bodyPr rtlCol="0" anchor="ctr" wrap="square" lIns="137160" rIns="137160" tIns="109728" bIns="109728"/>
           <a:lstStyle/>
           <a:p>
             <a:pPr algn="l">
@@ -7139,7 +8270,7 @@
             <a:r>
               <a:rPr sz="1090" b="1" i="0">
                 <a:solidFill>
-                  <a:srgbClr val="5E6E78"/>
+                  <a:srgbClr val="FFD23B"/>
                 </a:solidFill>
                 <a:latin typeface="Calibri (MS) Bold"/>
               </a:rPr>
@@ -7155,13 +8286,95 @@
             <a:r>
               <a:rPr sz="1440" b="1" i="0">
                 <a:solidFill>
-                  <a:srgbClr val="0B5E6E"/>
+                  <a:srgbClr val="FFFFFF"/>
                 </a:solidFill>
                 <a:latin typeface="Calibri (MS) Bold"/>
               </a:rPr>
               <a:t>Uji pada model penuh</a:t>
             </a:r>
           </a:p>
+        </p:txBody>
+      </p:sp>
+      <p:sp>
+        <p:nvSpPr>
+          <p:cNvPr id="199" name="TextBox 198"/>
+          <p:cNvSpPr txBox="1"/>
+          <p:nvPr/>
+        </p:nvSpPr>
+        <p:spPr>
+          <a:xfrm>
+            <a:off x="14401800" y="2633472"/>
+            <a:ext cx="2926080" cy="548640"/>
+          </a:xfrm>
+          <a:prstGeom prst="rect">
+            <a:avLst/>
+          </a:prstGeom>
+          <a:noFill/>
+        </p:spPr>
+        <p:txBody>
+          <a:bodyPr wrap="square" anchor="t" lIns="0" rIns="0" tIns="0" bIns="0">
+            <a:spAutoFit/>
+          </a:bodyPr>
+          <a:lstStyle/>
+          <a:p>
+            <a:pPr algn="l">
+              <a:spcAft>
+                <a:spcPts val="400"/>
+              </a:spcAft>
+            </a:pPr>
+            <a:r>
+              <a:rPr sz="1090" b="1" i="1">
+                <a:solidFill>
+                  <a:srgbClr val="14313B"/>
+                </a:solidFill>
+                <a:latin typeface="Calibri (MS) Bold"/>
+              </a:rPr>
+              <a:t>Laju konversi 0,0639 dari Tahap 2</a:t>
+            </a:r>
+          </a:p>
+        </p:txBody>
+      </p:sp>
+      <p:sp>
+        <p:nvSpPr>
+          <p:cNvPr id="200" name="Rounded Rectangle 199"/>
+          <p:cNvSpPr/>
+          <p:nvPr/>
+        </p:nvSpPr>
+        <p:spPr>
+          <a:xfrm>
+            <a:off x="14401800" y="3200400"/>
+            <a:ext cx="2926080" cy="384048"/>
+          </a:xfrm>
+          <a:prstGeom prst="roundRect">
+            <a:avLst>
+              <a:gd name="adj" fmla="val 8000"/>
+            </a:avLst>
+          </a:prstGeom>
+          <a:solidFill>
+            <a:srgbClr val="EAF8FA"/>
+          </a:solidFill>
+          <a:ln>
+            <a:noFill/>
+          </a:ln>
+          <a:effectLst/>
+        </p:spPr>
+        <p:style>
+          <a:lnRef idx="1">
+            <a:schemeClr val="accent1"/>
+          </a:lnRef>
+          <a:fillRef idx="3">
+            <a:schemeClr val="accent1"/>
+          </a:fillRef>
+          <a:effectRef idx="2">
+            <a:schemeClr val="accent1"/>
+          </a:effectRef>
+          <a:fontRef idx="minor">
+            <a:schemeClr val="lt1"/>
+          </a:fontRef>
+        </p:style>
+        <p:txBody>
+          <a:bodyPr rtlCol="0" anchor="ctr" wrap="square" lIns="73152" rIns="73152" tIns="73152" bIns="73152"/>
+          <a:lstStyle/>
           <a:p>
             <a:pPr algn="l">
               <a:spcAft>
@@ -7169,19 +8382,180 @@
               </a:spcAft>
             </a:pPr>
             <a:r>
-              <a:rPr sz="1150" b="1" i="1">
+              <a:rPr sz="1030" b="1" i="0">
+                <a:solidFill>
+                  <a:srgbClr val="0B5E6E"/>
+                </a:solidFill>
+                <a:latin typeface="Calibri (MS) Bold"/>
+              </a:rPr>
+              <a:t>Dicoba: </a:t>
+            </a:r>
+            <a:r>
+              <a:rPr sz="1030" b="0" i="0">
+                <a:solidFill>
+                  <a:srgbClr val="14313B"/>
+                </a:solidFill>
+                <a:latin typeface="Calibri (MS)"/>
+              </a:rPr>
+              <a:t>Dicoba pada 13 variabel yang dinilai</a:t>
+            </a:r>
+          </a:p>
+        </p:txBody>
+      </p:sp>
+      <p:sp>
+        <p:nvSpPr>
+          <p:cNvPr id="201" name="TextBox 200"/>
+          <p:cNvSpPr txBox="1"/>
+          <p:nvPr/>
+        </p:nvSpPr>
+        <p:spPr>
+          <a:xfrm>
+            <a:off x="14401800" y="3657600"/>
+            <a:ext cx="2926080" cy="685800"/>
+          </a:xfrm>
+          <a:prstGeom prst="rect">
+            <a:avLst/>
+          </a:prstGeom>
+          <a:noFill/>
+        </p:spPr>
+        <p:txBody>
+          <a:bodyPr wrap="square" anchor="t" lIns="0" rIns="0" tIns="0" bIns="0">
+            <a:spAutoFit/>
+          </a:bodyPr>
+          <a:lstStyle/>
+          <a:p>
+            <a:pPr algn="ctr">
+              <a:spcAft>
+                <a:spcPts val="400"/>
+              </a:spcAft>
+            </a:pPr>
+            <a:r>
+              <a:rPr sz="3220" b="1" i="0">
+                <a:solidFill>
+                  <a:srgbClr val="E4604F"/>
+                </a:solidFill>
+                <a:latin typeface="Calibri (MS) Bold"/>
+              </a:rPr>
+              <a:t>32,4%</a:t>
+            </a:r>
+          </a:p>
+        </p:txBody>
+      </p:sp>
+      <p:sp>
+        <p:nvSpPr>
+          <p:cNvPr id="202" name="TextBox 201"/>
+          <p:cNvSpPr txBox="1"/>
+          <p:nvPr/>
+        </p:nvSpPr>
+        <p:spPr>
+          <a:xfrm>
+            <a:off x="14401800" y="4370832"/>
+            <a:ext cx="2926080" cy="685800"/>
+          </a:xfrm>
+          <a:prstGeom prst="rect">
+            <a:avLst/>
+          </a:prstGeom>
+          <a:noFill/>
+        </p:spPr>
+        <p:txBody>
+          <a:bodyPr wrap="square" anchor="t" lIns="0" rIns="0" tIns="0" bIns="0">
+            <a:spAutoFit/>
+          </a:bodyPr>
+          <a:lstStyle/>
+          <a:p>
+            <a:pPr algn="ctr">
+              <a:spcAft>
+                <a:spcPts val="400"/>
+              </a:spcAft>
+            </a:pPr>
+            <a:r>
+              <a:rPr sz="1150" b="1" i="0">
                 <a:solidFill>
                   <a:srgbClr val="14313B"/>
                 </a:solidFill>
                 <a:latin typeface="Calibri (MS) Bold"/>
               </a:rPr>
-              <a:t>Laju konversi 0,0639 hasil Tahap 2</a:t>
-            </a:r>
-          </a:p>
+              <a:t>lahan terbangun (uji penuh) jadi kurang cocok</a:t>
+            </a:r>
+          </a:p>
+          <a:p>
+            <a:pPr algn="ctr">
+              <a:spcAft>
+                <a:spcPts val="400"/>
+              </a:spcAft>
+            </a:pPr>
+            <a:r>
+              <a:rPr sz="1090" b="0" i="0">
+                <a:solidFill>
+                  <a:srgbClr val="5E6E78"/>
+                </a:solidFill>
+                <a:latin typeface="Calibri (MS)"/>
+              </a:rPr>
+              <a:t>batas toleransi 5% · 12 variabel lain hampir tetap</a:t>
+            </a:r>
+          </a:p>
+        </p:txBody>
+      </p:sp>
+      <p:cxnSp>
+        <p:nvCxnSpPr>
+          <p:cNvPr id="203" name="Connector 202"/>
+          <p:cNvCxnSpPr/>
+          <p:nvPr/>
+        </p:nvCxnSpPr>
+        <p:spPr>
+          <a:xfrm>
+            <a:off x="14538960" y="5120640"/>
+            <a:ext cx="2651760" cy="0"/>
+          </a:xfrm>
+          <a:prstGeom prst="line">
+            <a:avLst/>
+          </a:prstGeom>
+          <a:ln w="12700">
+            <a:solidFill>
+              <a:srgbClr val="CFE5E9"/>
+            </a:solidFill>
+          </a:ln>
+        </p:spPr>
+        <p:style>
+          <a:lnRef idx="2">
+            <a:schemeClr val="accent1"/>
+          </a:lnRef>
+          <a:fillRef idx="0">
+            <a:schemeClr val="accent1"/>
+          </a:fillRef>
+          <a:effectRef idx="1">
+            <a:schemeClr val="accent1"/>
+          </a:effectRef>
+          <a:fontRef idx="minor">
+            <a:schemeClr val="tx1"/>
+          </a:fontRef>
+        </p:style>
+      </p:cxnSp>
+      <p:sp>
+        <p:nvSpPr>
+          <p:cNvPr id="204" name="TextBox 203"/>
+          <p:cNvSpPr txBox="1"/>
+          <p:nvPr/>
+        </p:nvSpPr>
+        <p:spPr>
+          <a:xfrm>
+            <a:off x="14401800" y="5193792"/>
+            <a:ext cx="2926080" cy="1600200"/>
+          </a:xfrm>
+          <a:prstGeom prst="rect">
+            <a:avLst/>
+          </a:prstGeom>
+          <a:noFill/>
+        </p:spPr>
+        <p:txBody>
+          <a:bodyPr wrap="square" anchor="t" lIns="0" rIns="0" tIns="0" bIns="0">
+            <a:spAutoFit/>
+          </a:bodyPr>
+          <a:lstStyle/>
           <a:p>
             <a:pPr algn="l">
               <a:spcAft>
-                <a:spcPts val="300"/>
+                <a:spcPts val="400"/>
               </a:spcAft>
             </a:pPr>
             <a:r>
@@ -7191,7 +8565,7 @@
                 </a:solidFill>
                 <a:latin typeface="Calibri (MS) Bold"/>
               </a:rPr>
-              <a:t>Yang dilakukan:  </a:t>
+              <a:t>Kenapa? </a:t>
             </a:r>
             <a:r>
               <a:rPr sz="1210" b="0" i="0">
@@ -7200,71 +8574,21 @@
                 </a:solidFill>
                 <a:latin typeface="Calibri (MS)"/>
               </a:rPr>
-              <a:t>Nilai 0,0639 dicoba pada model penuh dan uji parsial (13 variabel yang dinilai).</a:t>
-            </a:r>
-          </a:p>
-          <a:p>
-            <a:pPr algn="l">
-              <a:spcAft>
-                <a:spcPts val="300"/>
-              </a:spcAft>
-            </a:pPr>
-            <a:r>
-              <a:rPr sz="1210" b="1" i="0">
-                <a:solidFill>
-                  <a:srgbClr val="0B5E6E"/>
-                </a:solidFill>
-                <a:latin typeface="Calibri (MS) Bold"/>
-              </a:rPr>
-              <a:t>Hasilnya:  </a:t>
-            </a:r>
-            <a:r>
-              <a:rPr sz="1210" b="0" i="0">
-                <a:solidFill>
-                  <a:srgbClr val="14313B"/>
-                </a:solidFill>
-                <a:latin typeface="Calibri (MS)"/>
-              </a:rPr>
-              <a:t>12 variabel hampir tidak berubah, tetapi lahan terbangun pada uji penuh menjadi 32,4% kurang cocok (batas toleransi 5%; pemicu M1).</a:t>
-            </a:r>
-          </a:p>
-          <a:p>
-            <a:pPr algn="l">
-              <a:spcAft>
-                <a:spcPts val="300"/>
-              </a:spcAft>
-            </a:pPr>
-            <a:r>
-              <a:rPr sz="1210" b="1" i="0">
-                <a:solidFill>
-                  <a:srgbClr val="0B5E6E"/>
-                </a:solidFill>
-                <a:latin typeface="Calibri (MS) Bold"/>
-              </a:rPr>
-              <a:t>Penyebab:  </a:t>
-            </a:r>
-            <a:r>
-              <a:rPr sz="1210" b="0" i="0">
-                <a:solidFill>
-                  <a:srgbClr val="14313B"/>
-                </a:solidFill>
-                <a:latin typeface="Calibri (MS)"/>
-              </a:rPr>
-              <a:t>Uji P4 mulai 2016 saat lahan masih rendah, jadi laju lebih cepat membantu. Uji penuh mulai 2019 saat lahan sudah tinggi, jadi laju yang sama membuat simulasi melampaui data.</a:t>
-            </a:r>
-          </a:p>
-        </p:txBody>
-      </p:sp>
-      <p:sp>
-        <p:nvSpPr>
-          <p:cNvPr id="169" name="Rounded Rectangle 168"/>
+              <a:t>Uji penuh mulai 2019 saat lahan sudah tinggi, sehingga laju yang lebih cepat membuat simulasi melampaui data.</a:t>
+            </a:r>
+          </a:p>
+        </p:txBody>
+      </p:sp>
+      <p:sp>
+        <p:nvSpPr>
+          <p:cNvPr id="205" name="Rounded Rectangle 204"/>
           <p:cNvSpPr/>
           <p:nvPr/>
         </p:nvSpPr>
         <p:spPr>
           <a:xfrm>
-            <a:off x="14374367" y="6967728"/>
-            <a:ext cx="2980944" cy="685800"/>
+            <a:off x="14374367" y="6876288"/>
+            <a:ext cx="2980944" cy="731520"/>
           </a:xfrm>
           <a:prstGeom prst="roundRect">
             <a:avLst>
@@ -7303,20 +8627,36 @@
               </a:spcAft>
             </a:pPr>
             <a:r>
-              <a:rPr sz="1150" b="1" i="0">
+              <a:rPr sz="1210" b="1" i="0">
                 <a:solidFill>
                   <a:srgbClr val="FFFFFF"/>
                 </a:solidFill>
                 <a:latin typeface="Calibri (MS) Bold"/>
               </a:rPr>
-              <a:t>Ditolak: laju konversi kembali ke nilai dari data (0,0436)</a:t>
-            </a:r>
-          </a:p>
-        </p:txBody>
-      </p:sp>
-      <p:sp>
-        <p:nvSpPr>
-          <p:cNvPr id="170" name="Rounded Rectangle 169"/>
+              <a:t>Ditolak</a:t>
+            </a:r>
+          </a:p>
+          <a:p>
+            <a:pPr algn="ctr">
+              <a:spcAft>
+                <a:spcPts val="300"/>
+              </a:spcAft>
+            </a:pPr>
+            <a:r>
+              <a:rPr sz="1090" b="0" i="0">
+                <a:solidFill>
+                  <a:srgbClr val="FFFFFF"/>
+                </a:solidFill>
+                <a:latin typeface="Calibri (MS)"/>
+              </a:rPr>
+              <a:t>(kembali ke 0,0436)</a:t>
+            </a:r>
+          </a:p>
+        </p:txBody>
+      </p:sp>
+      <p:sp>
+        <p:nvSpPr>
+          <p:cNvPr id="206" name="Rounded Rectangle 205"/>
           <p:cNvSpPr/>
           <p:nvPr/>
         </p:nvSpPr>
@@ -7391,7 +8731,7 @@
       </p:sp>
       <p:sp>
         <p:nvSpPr>
-          <p:cNvPr id="171" name="TextBox 170"/>
+          <p:cNvPr id="207" name="TextBox 206"/>
           <p:cNvSpPr txBox="1"/>
           <p:nvPr/>
         </p:nvSpPr>

</xml_diff>